<commit_message>
docs(slides): honest leak-free 0.80462 + d3 = 0.701 (bbox+MIND) on metrics slide
Last slide now shows the true honest leak-free total (0.80462) as its own bar and
fixes per-dataset d3 from 0.442 (bbox) to 0.701 (bbox+MIND). Script writes directly
to EHL_Paris_Medical_Retrieval.pptx.

Co-Authored-By: Claude Opus 4.8 (1M context) <noreply@anthropic.com>
</commit_message>
<xml_diff>
--- a/EHL_Paris_Medical_Retrieval.pptx
+++ b/EHL_Paris_Medical_Retrieval.pptx
@@ -3233,7 +3233,7 @@
         </p:nvSpPr>
         <p:spPr>
           <a:xfrm>
-            <a:off x="822960" y="2148840"/>
+            <a:off x="822960" y="1783080"/>
             <a:ext cx="10515600" cy="1280160"/>
           </a:xfrm>
           <a:prstGeom prst="rect">
@@ -3278,7 +3278,7 @@
         </p:nvSpPr>
         <p:spPr>
           <a:xfrm>
-            <a:off x="822960" y="3154680"/>
+            <a:off x="841248" y="2743200"/>
             <a:ext cx="10515600" cy="640080"/>
           </a:xfrm>
           <a:prstGeom prst="rect">
@@ -3323,7 +3323,7 @@
         </p:nvSpPr>
         <p:spPr>
           <a:xfrm>
-            <a:off x="841248" y="4160520"/>
+            <a:off x="841248" y="3703320"/>
             <a:ext cx="10515600" cy="457200"/>
           </a:xfrm>
           <a:prstGeom prst="rect">
@@ -3368,7 +3368,7 @@
         </p:nvSpPr>
         <p:spPr>
           <a:xfrm>
-            <a:off x="841248" y="5029200"/>
+            <a:off x="841248" y="4526280"/>
             <a:ext cx="10515600" cy="457200"/>
           </a:xfrm>
           <a:prstGeom prst="rect">
@@ -7527,7 +7527,7 @@
                 </a:solidFill>
                 <a:latin typeface="Segoe UI"/>
               </a:rPr>
-              <a:t>WHY (OUR READING)</a:t>
+              <a:t>WHY</a:t>
             </a:r>
           </a:p>
         </p:txBody>
@@ -7896,7 +7896,7 @@
         </p:nvSpPr>
         <p:spPr>
           <a:xfrm>
-            <a:off x="594360" y="1874519"/>
+            <a:off x="594360" y="1783080"/>
             <a:ext cx="5120640" cy="365760"/>
           </a:xfrm>
           <a:prstGeom prst="rect">
@@ -7941,7 +7941,7 @@
         </p:nvSpPr>
         <p:spPr>
           <a:xfrm>
-            <a:off x="5760720" y="1920239"/>
+            <a:off x="5760720" y="1828800"/>
             <a:ext cx="3154954" cy="310896"/>
           </a:xfrm>
           <a:prstGeom prst="roundRect">
@@ -7985,7 +7985,7 @@
         </p:nvSpPr>
         <p:spPr>
           <a:xfrm>
-            <a:off x="10744200" y="1874519"/>
+            <a:off x="10744200" y="1783080"/>
             <a:ext cx="1280160" cy="365760"/>
           </a:xfrm>
           <a:prstGeom prst="rect">
@@ -8030,7 +8030,7 @@
         </p:nvSpPr>
         <p:spPr>
           <a:xfrm>
-            <a:off x="594360" y="2441448"/>
+            <a:off x="594360" y="2267712"/>
             <a:ext cx="5120640" cy="365760"/>
           </a:xfrm>
           <a:prstGeom prst="rect">
@@ -8075,7 +8075,7 @@
         </p:nvSpPr>
         <p:spPr>
           <a:xfrm>
-            <a:off x="5760720" y="2487168"/>
+            <a:off x="5760720" y="2313432"/>
             <a:ext cx="3479657" cy="310896"/>
           </a:xfrm>
           <a:prstGeom prst="roundRect">
@@ -8119,7 +8119,7 @@
         </p:nvSpPr>
         <p:spPr>
           <a:xfrm>
-            <a:off x="10744200" y="2441448"/>
+            <a:off x="10744200" y="2267712"/>
             <a:ext cx="1280160" cy="365760"/>
           </a:xfrm>
           <a:prstGeom prst="rect">
@@ -8164,7 +8164,7 @@
         </p:nvSpPr>
         <p:spPr>
           <a:xfrm>
-            <a:off x="594360" y="3008376"/>
+            <a:off x="594360" y="2752344"/>
             <a:ext cx="5120640" cy="365760"/>
           </a:xfrm>
           <a:prstGeom prst="rect">
@@ -8196,7 +8196,7 @@
                 </a:solidFill>
                 <a:latin typeface="Segoe UI"/>
               </a:rPr>
-              <a:t>+ d3 grid feature (if legitimate)</a:t>
+              <a:t>+ d3 bbox+MIND (honest leak-free)</a:t>
             </a:r>
           </a:p>
         </p:txBody>
@@ -8209,8 +8209,8 @@
         </p:nvSpPr>
         <p:spPr>
           <a:xfrm>
-            <a:off x="5760720" y="3054096"/>
-            <a:ext cx="4381073" cy="310896"/>
+            <a:off x="5760720" y="2798063"/>
+            <a:ext cx="3899445" cy="310896"/>
           </a:xfrm>
           <a:prstGeom prst="roundRect">
             <a:avLst/>
@@ -8253,7 +8253,7 @@
         </p:nvSpPr>
         <p:spPr>
           <a:xfrm>
-            <a:off x="10744200" y="3008376"/>
+            <a:off x="10744200" y="2752344"/>
             <a:ext cx="1280160" cy="365760"/>
           </a:xfrm>
           <a:prstGeom prst="rect">
@@ -8285,7 +8285,7 @@
                 </a:solidFill>
                 <a:latin typeface="Segoe UI"/>
               </a:rPr>
-              <a:t>0.904</a:t>
+              <a:t>0.80462</a:t>
             </a:r>
           </a:p>
         </p:txBody>
@@ -8298,8 +8298,8 @@
         </p:nvSpPr>
         <p:spPr>
           <a:xfrm>
-            <a:off x="594360" y="3657600"/>
-            <a:ext cx="11064240" cy="365760"/>
+            <a:off x="594360" y="3236976"/>
+            <a:ext cx="5120640" cy="365760"/>
           </a:xfrm>
           <a:prstGeom prst="rect">
             <a:avLst/>
@@ -8307,7 +8307,7 @@
           <a:noFill/>
         </p:spPr>
         <p:txBody>
-          <a:bodyPr wrap="square" anchor="t" lIns="0" rIns="0" tIns="0" bIns="0">
+          <a:bodyPr wrap="square" anchor="ctr" lIns="0" rIns="0" tIns="0" bIns="0">
             <a:spAutoFit/>
           </a:bodyPr>
           <a:lstStyle/>
@@ -8324,13 +8324,13 @@
               </a:spcAft>
             </a:pPr>
             <a:r>
-              <a:rPr sz="1300" b="1">
-                <a:solidFill>
-                  <a:srgbClr val="9DA7B3"/>
-                </a:solidFill>
-                <a:latin typeface="Segoe UI"/>
-              </a:rPr>
-              <a:t>Per-dataset (leak-free)</a:t>
+              <a:rPr sz="1400" b="0">
+                <a:solidFill>
+                  <a:srgbClr val="E6EDF3"/>
+                </a:solidFill>
+                <a:latin typeface="Segoe UI"/>
+              </a:rPr>
+              <a:t>+ d3 grid feature (if legitimate)</a:t>
             </a:r>
           </a:p>
         </p:txBody>
@@ -8343,14 +8343,14 @@
         </p:nvSpPr>
         <p:spPr>
           <a:xfrm>
-            <a:off x="594360" y="4069080"/>
-            <a:ext cx="3566160" cy="914400"/>
+            <a:off x="5760720" y="3282696"/>
+            <a:ext cx="4381073" cy="310896"/>
           </a:xfrm>
           <a:prstGeom prst="roundRect">
             <a:avLst/>
           </a:prstGeom>
           <a:solidFill>
-            <a:srgbClr val="161B22"/>
+            <a:srgbClr val="9DA7B3"/>
           </a:solidFill>
           <a:ln>
             <a:noFill/>
@@ -8381,58 +8381,14 @@
       </p:sp>
       <p:sp>
         <p:nvSpPr>
-          <p:cNvPr id="18" name="Rectangle 17"/>
-          <p:cNvSpPr/>
-          <p:nvPr/>
-        </p:nvSpPr>
-        <p:spPr>
-          <a:xfrm>
-            <a:off x="594360" y="4069080"/>
-            <a:ext cx="73152" cy="914400"/>
-          </a:xfrm>
-          <a:prstGeom prst="rect">
-            <a:avLst/>
-          </a:prstGeom>
-          <a:solidFill>
-            <a:srgbClr val="22D3EE"/>
-          </a:solidFill>
-          <a:ln>
-            <a:noFill/>
-          </a:ln>
-          <a:effectLst/>
-        </p:spPr>
-        <p:style>
-          <a:lnRef idx="1">
-            <a:schemeClr val="accent1"/>
-          </a:lnRef>
-          <a:fillRef idx="3">
-            <a:schemeClr val="accent1"/>
-          </a:fillRef>
-          <a:effectRef idx="2">
-            <a:schemeClr val="accent1"/>
-          </a:effectRef>
-          <a:fontRef idx="minor">
-            <a:schemeClr val="lt1"/>
-          </a:fontRef>
-        </p:style>
-        <p:txBody>
-          <a:bodyPr rtlCol="0" anchor="ctr"/>
-          <a:lstStyle/>
-          <a:p>
-            <a:pPr algn="ctr"/>
-          </a:p>
-        </p:txBody>
-      </p:sp>
-      <p:sp>
-        <p:nvSpPr>
-          <p:cNvPr id="19" name="TextBox 18"/>
+          <p:cNvPr id="18" name="TextBox 17"/>
           <p:cNvSpPr txBox="1"/>
           <p:nvPr/>
         </p:nvSpPr>
         <p:spPr>
           <a:xfrm>
-            <a:off x="822960" y="4187952"/>
-            <a:ext cx="3200400" cy="365760"/>
+            <a:off x="10744200" y="3236976"/>
+            <a:ext cx="1280160" cy="365760"/>
           </a:xfrm>
           <a:prstGeom prst="rect">
             <a:avLst/>
@@ -8440,7 +8396,7 @@
           <a:noFill/>
         </p:spPr>
         <p:txBody>
-          <a:bodyPr wrap="square" anchor="t" lIns="0" rIns="0" tIns="0" bIns="0">
+          <a:bodyPr wrap="square" anchor="ctr" lIns="0" rIns="0" tIns="0" bIns="0">
             <a:spAutoFit/>
           </a:bodyPr>
           <a:lstStyle/>
@@ -8457,27 +8413,27 @@
               </a:spcAft>
             </a:pPr>
             <a:r>
-              <a:rPr sz="1300" b="1">
+              <a:rPr sz="1500" b="1">
                 <a:solidFill>
                   <a:srgbClr val="9DA7B3"/>
                 </a:solidFill>
                 <a:latin typeface="Segoe UI"/>
               </a:rPr>
-              <a:t>dataset 1</a:t>
-            </a:r>
-          </a:p>
-        </p:txBody>
-      </p:sp>
-      <p:sp>
-        <p:nvSpPr>
-          <p:cNvPr id="20" name="TextBox 19"/>
+              <a:t>0.904</a:t>
+            </a:r>
+          </a:p>
+        </p:txBody>
+      </p:sp>
+      <p:sp>
+        <p:nvSpPr>
+          <p:cNvPr id="19" name="TextBox 18"/>
           <p:cNvSpPr txBox="1"/>
           <p:nvPr/>
         </p:nvSpPr>
         <p:spPr>
           <a:xfrm>
-            <a:off x="795528" y="4480560"/>
-            <a:ext cx="3200400" cy="457200"/>
+            <a:off x="594360" y="3703320"/>
+            <a:ext cx="11064240" cy="365760"/>
           </a:xfrm>
           <a:prstGeom prst="rect">
             <a:avLst/>
@@ -8502,26 +8458,26 @@
               </a:spcAft>
             </a:pPr>
             <a:r>
-              <a:rPr sz="2200" b="1">
-                <a:solidFill>
-                  <a:srgbClr val="22D3EE"/>
-                </a:solidFill>
-                <a:latin typeface="Segoe UI"/>
-              </a:rPr>
-              <a:t>0.964</a:t>
-            </a:r>
-          </a:p>
-        </p:txBody>
-      </p:sp>
-      <p:sp>
-        <p:nvSpPr>
-          <p:cNvPr id="21" name="Rounded Rectangle 20"/>
+              <a:rPr sz="1300" b="1">
+                <a:solidFill>
+                  <a:srgbClr val="9DA7B3"/>
+                </a:solidFill>
+                <a:latin typeface="Segoe UI"/>
+              </a:rPr>
+              <a:t>Per-dataset (leak-free)</a:t>
+            </a:r>
+          </a:p>
+        </p:txBody>
+      </p:sp>
+      <p:sp>
+        <p:nvSpPr>
+          <p:cNvPr id="20" name="Rounded Rectangle 19"/>
           <p:cNvSpPr/>
           <p:nvPr/>
         </p:nvSpPr>
         <p:spPr>
           <a:xfrm>
-            <a:off x="4389120" y="4069080"/>
+            <a:off x="594360" y="4069080"/>
             <a:ext cx="3566160" cy="914400"/>
           </a:xfrm>
           <a:prstGeom prst="roundRect">
@@ -8559,20 +8515,20 @@
       </p:sp>
       <p:sp>
         <p:nvSpPr>
-          <p:cNvPr id="22" name="Rectangle 21"/>
+          <p:cNvPr id="21" name="Rectangle 20"/>
           <p:cNvSpPr/>
           <p:nvPr/>
         </p:nvSpPr>
         <p:spPr>
           <a:xfrm>
-            <a:off x="4389120" y="4069080"/>
+            <a:off x="594360" y="4069080"/>
             <a:ext cx="73152" cy="914400"/>
           </a:xfrm>
           <a:prstGeom prst="rect">
             <a:avLst/>
           </a:prstGeom>
           <a:solidFill>
-            <a:srgbClr val="F472B6"/>
+            <a:srgbClr val="22D3EE"/>
           </a:solidFill>
           <a:ln>
             <a:noFill/>
@@ -8603,13 +8559,13 @@
       </p:sp>
       <p:sp>
         <p:nvSpPr>
-          <p:cNvPr id="23" name="TextBox 22"/>
+          <p:cNvPr id="22" name="TextBox 21"/>
           <p:cNvSpPr txBox="1"/>
           <p:nvPr/>
         </p:nvSpPr>
         <p:spPr>
           <a:xfrm>
-            <a:off x="4617720" y="4187952"/>
+            <a:off x="822960" y="4187952"/>
             <a:ext cx="3200400" cy="365760"/>
           </a:xfrm>
           <a:prstGeom prst="rect">
@@ -8641,20 +8597,20 @@
                 </a:solidFill>
                 <a:latin typeface="Segoe UI"/>
               </a:rPr>
-              <a:t>dataset 2</a:t>
-            </a:r>
-          </a:p>
-        </p:txBody>
-      </p:sp>
-      <p:sp>
-        <p:nvSpPr>
-          <p:cNvPr id="24" name="TextBox 23"/>
+              <a:t>dataset 1</a:t>
+            </a:r>
+          </a:p>
+        </p:txBody>
+      </p:sp>
+      <p:sp>
+        <p:nvSpPr>
+          <p:cNvPr id="23" name="TextBox 22"/>
           <p:cNvSpPr txBox="1"/>
           <p:nvPr/>
         </p:nvSpPr>
         <p:spPr>
           <a:xfrm>
-            <a:off x="4590288" y="4480560"/>
+            <a:off x="795528" y="4480560"/>
             <a:ext cx="3200400" cy="457200"/>
           </a:xfrm>
           <a:prstGeom prst="rect">
@@ -8682,24 +8638,24 @@
             <a:r>
               <a:rPr sz="2200" b="1">
                 <a:solidFill>
-                  <a:srgbClr val="F472B6"/>
-                </a:solidFill>
-                <a:latin typeface="Segoe UI"/>
-              </a:rPr>
-              <a:t>0.749  (wall)</a:t>
-            </a:r>
-          </a:p>
-        </p:txBody>
-      </p:sp>
-      <p:sp>
-        <p:nvSpPr>
-          <p:cNvPr id="25" name="Rounded Rectangle 24"/>
+                  <a:srgbClr val="22D3EE"/>
+                </a:solidFill>
+                <a:latin typeface="Segoe UI"/>
+              </a:rPr>
+              <a:t>0.964</a:t>
+            </a:r>
+          </a:p>
+        </p:txBody>
+      </p:sp>
+      <p:sp>
+        <p:nvSpPr>
+          <p:cNvPr id="24" name="Rounded Rectangle 23"/>
           <p:cNvSpPr/>
           <p:nvPr/>
         </p:nvSpPr>
         <p:spPr>
           <a:xfrm>
-            <a:off x="8183880" y="4069080"/>
+            <a:off x="4389120" y="4069080"/>
             <a:ext cx="3566160" cy="914400"/>
           </a:xfrm>
           <a:prstGeom prst="roundRect">
@@ -8737,20 +8693,20 @@
       </p:sp>
       <p:sp>
         <p:nvSpPr>
-          <p:cNvPr id="26" name="Rectangle 25"/>
+          <p:cNvPr id="25" name="Rectangle 24"/>
           <p:cNvSpPr/>
           <p:nvPr/>
         </p:nvSpPr>
         <p:spPr>
           <a:xfrm>
-            <a:off x="8183880" y="4069080"/>
+            <a:off x="4389120" y="4069080"/>
             <a:ext cx="73152" cy="914400"/>
           </a:xfrm>
           <a:prstGeom prst="rect">
             <a:avLst/>
           </a:prstGeom>
           <a:solidFill>
-            <a:srgbClr val="FBBF24"/>
+            <a:srgbClr val="F472B6"/>
           </a:solidFill>
           <a:ln>
             <a:noFill/>
@@ -8781,13 +8737,13 @@
       </p:sp>
       <p:sp>
         <p:nvSpPr>
-          <p:cNvPr id="27" name="TextBox 26"/>
+          <p:cNvPr id="26" name="TextBox 25"/>
           <p:cNvSpPr txBox="1"/>
           <p:nvPr/>
         </p:nvSpPr>
         <p:spPr>
           <a:xfrm>
-            <a:off x="8412480" y="4187952"/>
+            <a:off x="4617720" y="4187952"/>
             <a:ext cx="3200400" cy="365760"/>
           </a:xfrm>
           <a:prstGeom prst="rect">
@@ -8819,20 +8775,20 @@
                 </a:solidFill>
                 <a:latin typeface="Segoe UI"/>
               </a:rPr>
-              <a:t>dataset 3</a:t>
-            </a:r>
-          </a:p>
-        </p:txBody>
-      </p:sp>
-      <p:sp>
-        <p:nvSpPr>
-          <p:cNvPr id="28" name="TextBox 27"/>
+              <a:t>dataset 2</a:t>
+            </a:r>
+          </a:p>
+        </p:txBody>
+      </p:sp>
+      <p:sp>
+        <p:nvSpPr>
+          <p:cNvPr id="27" name="TextBox 26"/>
           <p:cNvSpPr txBox="1"/>
           <p:nvPr/>
         </p:nvSpPr>
         <p:spPr>
           <a:xfrm>
-            <a:off x="8385048" y="4480560"/>
+            <a:off x="4590288" y="4480560"/>
             <a:ext cx="3200400" cy="457200"/>
           </a:xfrm>
           <a:prstGeom prst="rect">
@@ -8860,18 +8816,196 @@
             <a:r>
               <a:rPr sz="2200" b="1">
                 <a:solidFill>
+                  <a:srgbClr val="F472B6"/>
+                </a:solidFill>
+                <a:latin typeface="Segoe UI"/>
+              </a:rPr>
+              <a:t>0.749  (wall)</a:t>
+            </a:r>
+          </a:p>
+        </p:txBody>
+      </p:sp>
+      <p:sp>
+        <p:nvSpPr>
+          <p:cNvPr id="28" name="Rounded Rectangle 27"/>
+          <p:cNvSpPr/>
+          <p:nvPr/>
+        </p:nvSpPr>
+        <p:spPr>
+          <a:xfrm>
+            <a:off x="8183880" y="4069080"/>
+            <a:ext cx="3566160" cy="914400"/>
+          </a:xfrm>
+          <a:prstGeom prst="roundRect">
+            <a:avLst/>
+          </a:prstGeom>
+          <a:solidFill>
+            <a:srgbClr val="161B22"/>
+          </a:solidFill>
+          <a:ln>
+            <a:noFill/>
+          </a:ln>
+          <a:effectLst/>
+        </p:spPr>
+        <p:style>
+          <a:lnRef idx="1">
+            <a:schemeClr val="accent1"/>
+          </a:lnRef>
+          <a:fillRef idx="3">
+            <a:schemeClr val="accent1"/>
+          </a:fillRef>
+          <a:effectRef idx="2">
+            <a:schemeClr val="accent1"/>
+          </a:effectRef>
+          <a:fontRef idx="minor">
+            <a:schemeClr val="lt1"/>
+          </a:fontRef>
+        </p:style>
+        <p:txBody>
+          <a:bodyPr rtlCol="0" anchor="ctr"/>
+          <a:lstStyle/>
+          <a:p>
+            <a:pPr algn="ctr"/>
+          </a:p>
+        </p:txBody>
+      </p:sp>
+      <p:sp>
+        <p:nvSpPr>
+          <p:cNvPr id="29" name="Rectangle 28"/>
+          <p:cNvSpPr/>
+          <p:nvPr/>
+        </p:nvSpPr>
+        <p:spPr>
+          <a:xfrm>
+            <a:off x="8183880" y="4069080"/>
+            <a:ext cx="73152" cy="914400"/>
+          </a:xfrm>
+          <a:prstGeom prst="rect">
+            <a:avLst/>
+          </a:prstGeom>
+          <a:solidFill>
+            <a:srgbClr val="FBBF24"/>
+          </a:solidFill>
+          <a:ln>
+            <a:noFill/>
+          </a:ln>
+          <a:effectLst/>
+        </p:spPr>
+        <p:style>
+          <a:lnRef idx="1">
+            <a:schemeClr val="accent1"/>
+          </a:lnRef>
+          <a:fillRef idx="3">
+            <a:schemeClr val="accent1"/>
+          </a:fillRef>
+          <a:effectRef idx="2">
+            <a:schemeClr val="accent1"/>
+          </a:effectRef>
+          <a:fontRef idx="minor">
+            <a:schemeClr val="lt1"/>
+          </a:fontRef>
+        </p:style>
+        <p:txBody>
+          <a:bodyPr rtlCol="0" anchor="ctr"/>
+          <a:lstStyle/>
+          <a:p>
+            <a:pPr algn="ctr"/>
+          </a:p>
+        </p:txBody>
+      </p:sp>
+      <p:sp>
+        <p:nvSpPr>
+          <p:cNvPr id="30" name="TextBox 29"/>
+          <p:cNvSpPr txBox="1"/>
+          <p:nvPr/>
+        </p:nvSpPr>
+        <p:spPr>
+          <a:xfrm>
+            <a:off x="8412480" y="4187952"/>
+            <a:ext cx="3200400" cy="365760"/>
+          </a:xfrm>
+          <a:prstGeom prst="rect">
+            <a:avLst/>
+          </a:prstGeom>
+          <a:noFill/>
+        </p:spPr>
+        <p:txBody>
+          <a:bodyPr wrap="square" anchor="t" lIns="0" rIns="0" tIns="0" bIns="0">
+            <a:spAutoFit/>
+          </a:bodyPr>
+          <a:lstStyle/>
+          <a:p>
+            <a:pPr algn="l">
+              <a:lnSpc>
+                <a:spcPct val="100000"/>
+              </a:lnSpc>
+              <a:spcBef>
+                <a:spcPts val="0"/>
+              </a:spcBef>
+              <a:spcAft>
+                <a:spcPts val="400"/>
+              </a:spcAft>
+            </a:pPr>
+            <a:r>
+              <a:rPr sz="1300" b="1">
+                <a:solidFill>
+                  <a:srgbClr val="9DA7B3"/>
+                </a:solidFill>
+                <a:latin typeface="Segoe UI"/>
+              </a:rPr>
+              <a:t>dataset 3</a:t>
+            </a:r>
+          </a:p>
+        </p:txBody>
+      </p:sp>
+      <p:sp>
+        <p:nvSpPr>
+          <p:cNvPr id="31" name="TextBox 30"/>
+          <p:cNvSpPr txBox="1"/>
+          <p:nvPr/>
+        </p:nvSpPr>
+        <p:spPr>
+          <a:xfrm>
+            <a:off x="8385048" y="4480560"/>
+            <a:ext cx="3200400" cy="457200"/>
+          </a:xfrm>
+          <a:prstGeom prst="rect">
+            <a:avLst/>
+          </a:prstGeom>
+          <a:noFill/>
+        </p:spPr>
+        <p:txBody>
+          <a:bodyPr wrap="square" anchor="t" lIns="0" rIns="0" tIns="0" bIns="0">
+            <a:spAutoFit/>
+          </a:bodyPr>
+          <a:lstStyle/>
+          <a:p>
+            <a:pPr algn="l">
+              <a:lnSpc>
+                <a:spcPct val="100000"/>
+              </a:lnSpc>
+              <a:spcBef>
+                <a:spcPts val="0"/>
+              </a:spcBef>
+              <a:spcAft>
+                <a:spcPts val="400"/>
+              </a:spcAft>
+            </a:pPr>
+            <a:r>
+              <a:rPr sz="2200" b="1">
+                <a:solidFill>
                   <a:srgbClr val="FBBF24"/>
                 </a:solidFill>
                 <a:latin typeface="Segoe UI"/>
               </a:rPr>
-              <a:t>0.442  (bbox)</a:t>
-            </a:r>
-          </a:p>
-        </p:txBody>
-      </p:sp>
-      <p:sp>
-        <p:nvSpPr>
-          <p:cNvPr id="29" name="TextBox 28"/>
+              <a:t>0.701  (bbox+MIND)</a:t>
+            </a:r>
+          </a:p>
+        </p:txBody>
+      </p:sp>
+      <p:sp>
+        <p:nvSpPr>
+          <p:cNvPr id="32" name="TextBox 31"/>
           <p:cNvSpPr txBox="1"/>
           <p:nvPr/>
         </p:nvSpPr>
@@ -8909,7 +9043,7 @@
                 </a:solidFill>
                 <a:latin typeface="Segoe UI"/>
               </a:rPr>
-              <a:t>Hungarian is worth +0.068. The reproduced leak hits 0.931 — but our honest pipeline tops out at 0.718 (strict) / 0.904 (d3-grid), and d2's elastic warp is the genuine remaining wall.</a:t>
+              <a:t>Hungarian is worth +0.068. Honest leak-free tops out at 0.80462 (d3 bbox+MIND); counting the d3 geometry shortcut gives 0.904. The reproduced leak hits 0.931 — d2's elastic warp is the genuine wall.</a:t>
             </a:r>
           </a:p>
         </p:txBody>

</xml_diff>